<commit_message>
Size task_detail panels to their content with measured text, stricter sourcing rules for numbers and plans, Antigravity no longer experimental
</commit_message>
<xml_diff>
--- a/docs/example-deck-corporate.pptx
+++ b/docs/example-deck-corporate.pptx
@@ -3703,7 +3703,7 @@
       </p:sp>
       <p:pic>
         <p:nvPicPr>
-          <p:cNvPr id="4" name="Image 0" descr="/var/folders/lw/rmylcyvd5rjfxk9g1z9rrm8w0000gq/T/showship-deck-zUwgzA/logo_trimmed.png">    </p:cNvPr>
+          <p:cNvPr id="4" name="Image 0" descr="/var/folders/lw/rmylcyvd5rjfxk9g1z9rrm8w0000gq/T/showship-deck-nCMvmZ/logo_trimmed.png">    </p:cNvPr>
           <p:cNvPicPr>
             <a:picLocks noChangeAspect="1"/>
           </p:cNvPicPr>
@@ -6320,7 +6320,7 @@
       </p:sp>
       <p:pic>
         <p:nvPicPr>
-          <p:cNvPr id="4" name="Image 0" descr="/var/folders/lw/rmylcyvd5rjfxk9g1z9rrm8w0000gq/T/showship-deck-zUwgzA/logo_trimmed.png">    </p:cNvPr>
+          <p:cNvPr id="4" name="Image 0" descr="/var/folders/lw/rmylcyvd5rjfxk9g1z9rrm8w0000gq/T/showship-deck-nCMvmZ/logo_trimmed.png">    </p:cNvPr>
           <p:cNvPicPr>
             <a:picLocks noChangeAspect="1"/>
           </p:cNvPicPr>
@@ -10747,7 +10747,7 @@
         <p:spPr>
           <a:xfrm>
             <a:off x="640080" y="1783080"/>
-            <a:ext cx="3453384" cy="4160520"/>
+            <a:ext cx="3453384" cy="3694938"/>
           </a:xfrm>
           <a:prstGeom prst="rect">
             <a:avLst/>
@@ -11293,7 +11293,7 @@
         <p:spPr>
           <a:xfrm>
             <a:off x="4367784" y="1783080"/>
-            <a:ext cx="3453384" cy="4160520"/>
+            <a:ext cx="3453384" cy="3694938"/>
           </a:xfrm>
           <a:prstGeom prst="rect">
             <a:avLst/>
@@ -11617,7 +11617,7 @@
         <p:spPr>
           <a:xfrm>
             <a:off x="4843272" y="4536186"/>
-            <a:ext cx="2749296" cy="390144"/>
+            <a:ext cx="2749296" cy="222504"/>
           </a:xfrm>
           <a:prstGeom prst="rect">
             <a:avLst/>
@@ -11655,7 +11655,7 @@
         </p:nvSpPr>
         <p:spPr>
           <a:xfrm>
-            <a:off x="4596384" y="4981194"/>
+            <a:off x="4596384" y="4813554"/>
             <a:ext cx="118872" cy="118872"/>
           </a:xfrm>
           <a:prstGeom prst="ellipse">
@@ -11675,7 +11675,7 @@
         </p:nvSpPr>
         <p:spPr>
           <a:xfrm>
-            <a:off x="4843272" y="4926330"/>
+            <a:off x="4843272" y="4758690"/>
             <a:ext cx="2749296" cy="222504"/>
           </a:xfrm>
           <a:prstGeom prst="rect">
@@ -11714,7 +11714,7 @@
         </p:nvSpPr>
         <p:spPr>
           <a:xfrm>
-            <a:off x="4596384" y="5203698"/>
+            <a:off x="4596384" y="5036058"/>
             <a:ext cx="118872" cy="118872"/>
           </a:xfrm>
           <a:prstGeom prst="ellipse">
@@ -11734,7 +11734,7 @@
         </p:nvSpPr>
         <p:spPr>
           <a:xfrm>
-            <a:off x="4843272" y="5148834"/>
+            <a:off x="4843272" y="4981194"/>
             <a:ext cx="2749296" cy="222504"/>
           </a:xfrm>
           <a:prstGeom prst="rect">
@@ -11774,7 +11774,7 @@
         <p:spPr>
           <a:xfrm>
             <a:off x="8095488" y="1783080"/>
-            <a:ext cx="3453384" cy="4160520"/>
+            <a:ext cx="3453384" cy="3694938"/>
           </a:xfrm>
           <a:prstGeom prst="rect">
             <a:avLst/>
@@ -11938,7 +11938,7 @@
         <p:spPr>
           <a:xfrm>
             <a:off x="8324088" y="2871597"/>
-            <a:ext cx="2996184" cy="792480"/>
+            <a:ext cx="2996184" cy="594360"/>
           </a:xfrm>
           <a:prstGeom prst="rect">
             <a:avLst/>
@@ -11979,7 +11979,7 @@
         </p:nvSpPr>
         <p:spPr>
           <a:xfrm>
-            <a:off x="8324088" y="3801237"/>
+            <a:off x="8324088" y="3603117"/>
             <a:ext cx="2996184" cy="228600"/>
           </a:xfrm>
           <a:prstGeom prst="rect">
@@ -12018,7 +12018,7 @@
         </p:nvSpPr>
         <p:spPr>
           <a:xfrm>
-            <a:off x="8324088" y="4130421"/>
+            <a:off x="8324088" y="3932301"/>
             <a:ext cx="118872" cy="118872"/>
           </a:xfrm>
           <a:prstGeom prst="ellipse">
@@ -12040,7 +12040,7 @@
         </p:nvSpPr>
         <p:spPr>
           <a:xfrm>
-            <a:off x="8570976" y="4075557"/>
+            <a:off x="8570976" y="3877437"/>
             <a:ext cx="2749296" cy="222504"/>
           </a:xfrm>
           <a:prstGeom prst="rect">
@@ -12079,7 +12079,7 @@
         </p:nvSpPr>
         <p:spPr>
           <a:xfrm>
-            <a:off x="8324088" y="4352925"/>
+            <a:off x="8324088" y="4154805"/>
             <a:ext cx="118872" cy="118872"/>
           </a:xfrm>
           <a:prstGeom prst="ellipse">
@@ -12101,7 +12101,7 @@
         </p:nvSpPr>
         <p:spPr>
           <a:xfrm>
-            <a:off x="8570976" y="4298061"/>
+            <a:off x="8570976" y="4099941"/>
             <a:ext cx="2749296" cy="222504"/>
           </a:xfrm>
           <a:prstGeom prst="rect">
@@ -12140,7 +12140,7 @@
         </p:nvSpPr>
         <p:spPr>
           <a:xfrm>
-            <a:off x="8324088" y="4575429"/>
+            <a:off x="8324088" y="4377309"/>
             <a:ext cx="118872" cy="118872"/>
           </a:xfrm>
           <a:prstGeom prst="ellipse">
@@ -12162,7 +12162,7 @@
         </p:nvSpPr>
         <p:spPr>
           <a:xfrm>
-            <a:off x="8570976" y="4520565"/>
+            <a:off x="8570976" y="4322445"/>
             <a:ext cx="2749296" cy="222504"/>
           </a:xfrm>
           <a:prstGeom prst="rect">
@@ -12201,7 +12201,7 @@
         </p:nvSpPr>
         <p:spPr>
           <a:xfrm>
-            <a:off x="640080" y="5989320"/>
+            <a:off x="640080" y="5615178"/>
             <a:ext cx="10908792" cy="274320"/>
           </a:xfrm>
           <a:prstGeom prst="rect">

</xml_diff>

<commit_message>
Lint fails status words that disagree with state and plan rows marked done, rebuild drops stale check images, example plan row fixed
</commit_message>
<xml_diff>
--- a/docs/example-deck-corporate.pptx
+++ b/docs/example-deck-corporate.pptx
@@ -3703,7 +3703,7 @@
       </p:sp>
       <p:pic>
         <p:nvPicPr>
-          <p:cNvPr id="4" name="Image 0" descr="/var/folders/lw/rmylcyvd5rjfxk9g1z9rrm8w0000gq/T/showship-deck-nCMvmZ/logo_trimmed.png">    </p:cNvPr>
+          <p:cNvPr id="4" name="Image 0" descr="/var/folders/lw/rmylcyvd5rjfxk9g1z9rrm8w0000gq/T/showship-deck-lMKZj0/logo_trimmed.png">    </p:cNvPr>
           <p:cNvPicPr>
             <a:picLocks noChangeAspect="1"/>
           </p:cNvPicPr>
@@ -6184,13 +6184,13 @@
                       <a:r>
                         <a:rPr lang="en-US" sz="1100" b="1" dirty="0">
                           <a:solidFill>
-                            <a:srgbClr val="FFFFFF"/>
+                            <a:srgbClr val="4B5563"/>
                           </a:solidFill>
                           <a:latin typeface="Arial" pitchFamily="34" charset="0"/>
                           <a:ea typeface="Arial" pitchFamily="34" charset="-122"/>
                           <a:cs typeface="Arial" pitchFamily="34" charset="-120"/>
                         </a:rPr>
-                        <a:t>DONE</a:t>
+                        <a:t>NOT STARTED</a:t>
                       </a:r>
                       <a:endParaRPr lang="en-US" sz="1100" dirty="0">
                         <a:latin typeface="Arial" charset="0"/>
@@ -6237,7 +6237,7 @@
                       <a:tailEnd type="none" w="med" len="med"/>
                     </a:lnB>
                     <a:solidFill>
-                      <a:srgbClr val="2563EB"/>
+                      <a:srgbClr val="E5E9F0"/>
                     </a:solidFill>
                   </a:tcPr>
                 </a:tc>
@@ -6320,7 +6320,7 @@
       </p:sp>
       <p:pic>
         <p:nvPicPr>
-          <p:cNvPr id="4" name="Image 0" descr="/var/folders/lw/rmylcyvd5rjfxk9g1z9rrm8w0000gq/T/showship-deck-nCMvmZ/logo_trimmed.png">    </p:cNvPr>
+          <p:cNvPr id="4" name="Image 0" descr="/var/folders/lw/rmylcyvd5rjfxk9g1z9rrm8w0000gq/T/showship-deck-lMKZj0/logo_trimmed.png">    </p:cNvPr>
           <p:cNvPicPr>
             <a:picLocks noChangeAspect="1"/>
           </p:cNvPicPr>

</xml_diff>

<commit_message>
0.1.0-beta.19: Summit design for reports to the CEO, review chip no longer overlaps text
</commit_message>
<xml_diff>
--- a/docs/example-deck-corporate.pptx
+++ b/docs/example-deck-corporate.pptx
@@ -3703,7 +3703,7 @@
       </p:sp>
       <p:pic>
         <p:nvPicPr>
-          <p:cNvPr id="4" name="Image 0" descr="/var/folders/lw/rmylcyvd5rjfxk9g1z9rrm8w0000gq/T/showship-deck-lMKZj0/logo_trimmed.png">    </p:cNvPr>
+          <p:cNvPr id="4" name="Image 0" descr="/var/folders/lw/rmylcyvd5rjfxk9g1z9rrm8w0000gq/T/showship-deck-IA2uJl/logo_trimmed.png">    </p:cNvPr>
           <p:cNvPicPr>
             <a:picLocks noChangeAspect="1"/>
           </p:cNvPicPr>
@@ -6320,7 +6320,7 @@
       </p:sp>
       <p:pic>
         <p:nvPicPr>
-          <p:cNvPr id="4" name="Image 0" descr="/var/folders/lw/rmylcyvd5rjfxk9g1z9rrm8w0000gq/T/showship-deck-lMKZj0/logo_trimmed.png">    </p:cNvPr>
+          <p:cNvPr id="4" name="Image 0" descr="/var/folders/lw/rmylcyvd5rjfxk9g1z9rrm8w0000gq/T/showship-deck-IA2uJl/logo_trimmed.png">    </p:cNvPr>
           <p:cNvPicPr>
             <a:picLocks noChangeAspect="1"/>
           </p:cNvPicPr>
@@ -12858,7 +12858,7 @@
         <p:spPr>
           <a:xfrm>
             <a:off x="4389120" y="2304288"/>
-            <a:ext cx="5376672" cy="801624"/>
+            <a:ext cx="5751576" cy="801624"/>
           </a:xfrm>
           <a:prstGeom prst="rect">
             <a:avLst/>
@@ -13022,7 +13022,7 @@
         <p:spPr>
           <a:xfrm>
             <a:off x="4389120" y="3544824"/>
-            <a:ext cx="5376672" cy="801624"/>
+            <a:ext cx="4837176" cy="801624"/>
           </a:xfrm>
           <a:prstGeom prst="rect">
             <a:avLst/>
@@ -13186,7 +13186,7 @@
         <p:spPr>
           <a:xfrm>
             <a:off x="4389120" y="4785360"/>
-            <a:ext cx="5376672" cy="801624"/>
+            <a:ext cx="5751576" cy="801624"/>
           </a:xfrm>
           <a:prstGeom prst="rect">
             <a:avLst/>

</xml_diff>